<commit_message>
Add full English mirror of the site and apply the station pricing terms
- Every page now exists in Spanish and English (/en/...), with a language
  switch that lands on the equivalent page and hreflang/x-default alternates
- Nav, footer, cookie notice, map popups/cards and form messages are
  localized from the page language
- Pricing terms across site and deck: 25 bps below the station's current
  contract, no monthly minimum, terminal on monthly rental, transactions
  cleared in US dollars; savings calculator on both pricing pages
- Contact function forwards every form field; sign-up links from map cards
  pre-fill the station name
- Rewrote main.js cleanly after partial patches

Co-Authored-By: Claude Fable 5.1 <noreply@anthropic.com>
Claude-Session: https://claude.ai/code/session_011LzCqa4EdedXHEQKz3UeTy
</commit_message>
<xml_diff>
--- a/deck/Wallet-Partners-Sponsor-Bank-Deck.pptx
+++ b/deck/Wallet-Partners-Sponsor-Bank-Deck.pptx
@@ -1737,7 +1737,7 @@
           <a:p>
             <a:r>
               <a:rPr lang="en-US" dirty="0"/>
-              <a:t>Walk through the 20-station case only; the 10 and 40 cases show sensitivity. Emphasise that pricing per gallon can land below today's effective rate for the station while still clearing interchange.</a:t>
+              <a:t>Walk through the 20-station case only; the 10 and 40 cases show sensitivity. Merchant pricing is 25 bps below each station's current contract, so the gross MDR shown at 1.95% is a ceiling for stations currently at 2.20%.</a:t>
             </a:r>
             <a:endParaRPr lang="en-US" dirty="0"/>
           </a:p>
@@ -3331,7 +3331,7 @@
                 <a:ea typeface="Calibri" pitchFamily="34" charset="-122"/>
                 <a:cs typeface="Calibri" pitchFamily="34" charset="-120"/>
               </a:rPr>
-              <a:t>A per-gallon acquiring program for the Dominican Republic, operated by Wallet Partners LLC under the sponsorship of a licensed member bank.</a:t>
+              <a:t>A fuel-retail acquiring program for the Dominican Republic, cleared in US dollars and operated by Wallet Partners LLC under the sponsorship of a licensed member bank.</a:t>
             </a:r>
             <a:endParaRPr lang="en-US" sz="1500" dirty="0"/>
           </a:p>
@@ -4215,7 +4215,7 @@
                 <a:ea typeface="Calibri" pitchFamily="34" charset="-122"/>
                 <a:cs typeface="Calibri" pitchFamily="34" charset="-120"/>
               </a:rPr>
-              <a:t>Networks settle to the bank's program account. We pay each station next business day in pesos, net of the per-gallon fee.</a:t>
+              <a:t>Networks settle to the bank's program account in US dollars. We pay each station in dollars, net of the agreed rate.</a:t>
             </a:r>
             <a:endParaRPr lang="en-US" sz="1100" dirty="0"/>
           </a:p>
@@ -5977,7 +5977,7 @@
                           <a:ea typeface="Calibri" pitchFamily="34" charset="-122"/>
                           <a:cs typeface="Calibri" pitchFamily="34" charset="-120"/>
                         </a:rPr>
-                        <a:t>Sets per-gallon pricing within approved parameters</a:t>
+                        <a:t>Quotes 25 bps below the station's current contract, no monthly minimum, terminal rental</a:t>
                       </a:r>
                       <a:endParaRPr lang="en-US" sz="1000" dirty="0">
                         <a:latin typeface="Calibri" charset="0"/>
@@ -6174,7 +6174,7 @@
                           <a:ea typeface="Calibri" pitchFamily="34" charset="-122"/>
                           <a:cs typeface="Calibri" pitchFamily="34" charset="-120"/>
                         </a:rPr>
-                        <a:t>Pays stations next day from program account; maintains reserves</a:t>
+                        <a:t>Pays stations in US dollars from program account; maintains reserves</a:t>
                       </a:r>
                       <a:endParaRPr lang="en-US" sz="1000" dirty="0">
                         <a:latin typeface="Calibri" charset="0"/>
@@ -7262,7 +7262,7 @@
                 <a:ea typeface="Calibri" pitchFamily="34" charset="-122"/>
                 <a:cs typeface="Calibri" pitchFamily="34" charset="-120"/>
               </a:rPr>
-              <a:t>A product built around gallons, forecourts and night shifts</a:t>
+              <a:t>A product built around forecourts, night shifts and a simple price</a:t>
             </a:r>
             <a:endParaRPr lang="en-US" sz="1400" dirty="0"/>
           </a:p>
@@ -7413,7 +7413,7 @@
                 <a:ea typeface="Calibri" pitchFamily="34" charset="-122"/>
                 <a:cs typeface="Calibri" pitchFamily="34" charset="-120"/>
               </a:rPr>
-              <a:t>Per-gallon pricing</a:t>
+              <a:t>25 bps below today</a:t>
             </a:r>
             <a:endParaRPr lang="en-US" sz="1300" dirty="0"/>
           </a:p>
@@ -7452,7 +7452,7 @@
                 <a:ea typeface="Calibri" pitchFamily="34" charset="-122"/>
                 <a:cs typeface="Calibri" pitchFamily="34" charset="-120"/>
               </a:rPr>
-              <a:t>Fee in pesos per gallon with a cap; interchange-plus statements the owner can check against the weekly MICM notice.</a:t>
+              <a:t>Rate 0.25 points below the station's current contract, no monthly minimum; interchange-plus statements the owner can compare line by line.</a:t>
             </a:r>
             <a:endParaRPr lang="en-US" sz="1000" dirty="0"/>
           </a:p>
@@ -7540,7 +7540,7 @@
                 <a:ea typeface="Calibri" pitchFamily="34" charset="-122"/>
                 <a:cs typeface="Calibri" pitchFamily="34" charset="-120"/>
               </a:rPr>
-              <a:t>Next-day pesos</a:t>
+              <a:t>Cleared in dollars</a:t>
             </a:r>
             <a:endParaRPr lang="en-US" sz="1300" dirty="0"/>
           </a:p>
@@ -7579,7 +7579,7 @@
                 <a:ea typeface="Calibri" pitchFamily="34" charset="-122"/>
                 <a:cs typeface="Calibri" pitchFamily="34" charset="-120"/>
               </a:rPr>
-              <a:t>Settlement next business day, per station, with shift-level reconciliation; less cash on 24-hour sites.</a:t>
+              <a:t>Transactions cleared in US dollars, per station, with shift-level reconciliation; terminals on monthly rental with replacement included.</a:t>
             </a:r>
             <a:endParaRPr lang="en-US" sz="1000" dirty="0"/>
           </a:p>
@@ -9436,7 +9436,7 @@
                 <a:ea typeface="Calibri" pitchFamily="34" charset="-122"/>
                 <a:cs typeface="Calibri" pitchFamily="34" charset="-120"/>
               </a:rPr>
-              <a:t>Card volume per station RD$3.3 MM per month, the national average implied by RD$41 bn a year across about 1,025 stations; Polígono Central sites are expected to run above it. Effective MDR 1.95% (the low end of today's range). Exchange rate RD$62 per US$. Interchange, network fees, terminal costs and the bank's share are not deducted; the revenue split is a negotiation item.</a:t>
+              <a:t>Card volume per station RD$3.3 MM per month, the national average implied by RD$41 bn a year across about 1,025 stations; Polígono Central sites are expected to run above it. Effective MDR 1.95%, i.e. 25 bps below a station currently paying 2.20%. Exchange rate RD$62 per US$. Interchange, network fees, terminal costs and the bank's share are not deducted; the revenue split is a negotiation item.</a:t>
             </a:r>
             <a:endParaRPr lang="en-US" sz="1050" dirty="0"/>
           </a:p>
@@ -12801,7 +12801,7 @@
                 <a:ea typeface="Calibri" pitchFamily="34" charset="-122"/>
                 <a:cs typeface="Calibri" pitchFamily="34" charset="-120"/>
               </a:rPr>
-              <a:t>Per-gallon pricing with a cap, interchange-plus statements, forecourt EMV/contactless terminals, next-day peso settlement.</a:t>
+              <a:t>Merchant pricing 25 bps below each station's current contract, no monthly minimum, terminals on monthly rental, transactions cleared in US dollars.</a:t>
             </a:r>
             <a:endParaRPr lang="en-US" sz="1250" dirty="0"/>
           </a:p>
@@ -13931,7 +13931,7 @@
                 <a:ea typeface="Calibri" pitchFamily="34" charset="-122"/>
                 <a:cs typeface="Calibri" pitchFamily="34" charset="-120"/>
               </a:rPr>
-              <a:t>The retailers' own numbers show the problem is the pricing structure, not card acceptance. A per-gallon program gives a bank a defensible way to grow fuel-segment volume while the incumbents are locked in a public dispute with the segment.</a:t>
+              <a:t>The retailers' own numbers show that price, not card acceptance, is the issue. A program priced 25 bps below each station's current contract, with no monthly minimum, gives a bank a defensible way to grow fuel-segment volume while the incumbents are locked in a public dispute with the segment.</a:t>
             </a:r>
             <a:endParaRPr lang="en-US" sz="1200" dirty="0"/>
           </a:p>
@@ -16131,7 +16131,7 @@
                 <a:ea typeface="Calibri" pitchFamily="34" charset="-122"/>
                 <a:cs typeface="Calibri" pitchFamily="34" charset="-120"/>
               </a:rPr>
-              <a:t>CardNET (bank-owned), AZUL (Grupo Popular, 2014) and Visanet Dominicana. All three price fuel like any other retail category; none offers gallon-based pricing, fleet cards or forecourt integration.</a:t>
+              <a:t>CardNET (bank-owned), AZUL (Grupo Popular, 2014) and Visanet Dominicana. All three price fuel like any other retail category; none offers a fuel-specific program, fleet cards or forecourt integration.</a:t>
             </a:r>
             <a:endParaRPr lang="en-US" sz="1150" dirty="0"/>
           </a:p>

</xml_diff>

<commit_message>
Rebrand the site and deck as Bombero Partners, a DBA of Wallet Partners LLC
Customer-facing name is Bombero Partners on every page, header, footer,
titles, manifest and structured data (legalName stays Wallet Partners LLC).
Legal pages state the trade-name relationship; deck cover and footers carry
'Wallet Partners LLC d/b/a Bombero Partners'. Launch checklist gains the DBA
and ONAPI trade-name registration item.

Co-Authored-By: Claude Fable 5.1 <noreply@anthropic.com>
Claude-Session: https://claude.ai/code/session_011LzCqa4EdedXHEQKz3UeTy
</commit_message>
<xml_diff>
--- a/deck/Wallet-Partners-Sponsor-Bank-Deck.pptx
+++ b/deck/Wallet-Partners-Sponsor-Bank-Deck.pptx
@@ -3331,7 +3331,7 @@
                 <a:ea typeface="Calibri" pitchFamily="34" charset="-122"/>
                 <a:cs typeface="Calibri" pitchFamily="34" charset="-120"/>
               </a:rPr>
-              <a:t>A fuel-retail acquiring program for the Dominican Republic, cleared in US dollars and operated by Wallet Partners LLC under the sponsorship of a licensed member bank.</a:t>
+              <a:t>Bombero Partners: a fuel-retail acquiring program for the Dominican Republic, cleared in US dollars and operated by Wallet Partners LLC under the sponsorship of a licensed member bank.</a:t>
             </a:r>
             <a:endParaRPr lang="en-US" sz="1500" dirty="0"/>
           </a:p>
@@ -3370,7 +3370,7 @@
                 <a:ea typeface="Calibri" pitchFamily="34" charset="-122"/>
                 <a:cs typeface="Calibri" pitchFamily="34" charset="-120"/>
               </a:rPr>
-              <a:t>Wallet Partners LLC  ·  September 2026  ·  Confidential</a:t>
+              <a:t>Wallet Partners LLC d/b/a Bombero Partners  ·  bomberopartners.com.do  ·  September 2026  ·  Confidential</a:t>
             </a:r>
             <a:endParaRPr lang="en-US" sz="1100" dirty="0"/>
           </a:p>
@@ -3441,7 +3441,7 @@
                 <a:ea typeface="Calibri" pitchFamily="34" charset="-122"/>
                 <a:cs typeface="Calibri" pitchFamily="34" charset="-120"/>
               </a:rPr>
-              <a:t>Wallet Partners LLC · Sponsor-bank briefing · September 2026 · Confidential</a:t>
+              <a:t>Wallet Partners LLC d/b/a Bombero Partners · Sponsor-bank briefing · September 2026 · Confidential</a:t>
             </a:r>
             <a:endParaRPr lang="en-US" sz="900" dirty="0"/>
           </a:p>
@@ -4750,7 +4750,7 @@
                 <a:ea typeface="Calibri" pitchFamily="34" charset="-122"/>
                 <a:cs typeface="Calibri" pitchFamily="34" charset="-120"/>
               </a:rPr>
-              <a:t>Wallet Partners LLC · Sponsor-bank briefing · September 2026 · Confidential</a:t>
+              <a:t>Wallet Partners LLC d/b/a Bombero Partners · Sponsor-bank briefing · September 2026 · Confidential</a:t>
             </a:r>
             <a:endParaRPr lang="en-US" sz="900" dirty="0"/>
           </a:p>
@@ -7145,7 +7145,7 @@
                 <a:ea typeface="Calibri" pitchFamily="34" charset="-122"/>
                 <a:cs typeface="Calibri" pitchFamily="34" charset="-120"/>
               </a:rPr>
-              <a:t>Wallet Partners LLC · Sponsor-bank briefing · September 2026 · Confidential</a:t>
+              <a:t>Wallet Partners LLC d/b/a Bombero Partners · Sponsor-bank briefing · September 2026 · Confidential</a:t>
             </a:r>
             <a:endParaRPr lang="en-US" sz="900" dirty="0"/>
           </a:p>
@@ -8158,7 +8158,7 @@
                 <a:ea typeface="Calibri" pitchFamily="34" charset="-122"/>
                 <a:cs typeface="Calibri" pitchFamily="34" charset="-120"/>
               </a:rPr>
-              <a:t>Wallet Partners LLC · Sponsor-bank briefing · September 2026 · Confidential</a:t>
+              <a:t>Wallet Partners LLC d/b/a Bombero Partners · Sponsor-bank briefing · September 2026 · Confidential</a:t>
             </a:r>
             <a:endParaRPr lang="en-US" sz="900" dirty="0"/>
           </a:p>
@@ -9507,7 +9507,7 @@
                 <a:ea typeface="Calibri" pitchFamily="34" charset="-122"/>
                 <a:cs typeface="Calibri" pitchFamily="34" charset="-120"/>
               </a:rPr>
-              <a:t>Wallet Partners LLC · Sponsor-bank briefing · September 2026 · Confidential</a:t>
+              <a:t>Wallet Partners LLC d/b/a Bombero Partners · Sponsor-bank briefing · September 2026 · Confidential</a:t>
             </a:r>
             <a:endParaRPr lang="en-US" sz="900" dirty="0"/>
           </a:p>
@@ -10125,7 +10125,7 @@
                 <a:ea typeface="Calibri" pitchFamily="34" charset="-122"/>
                 <a:cs typeface="Calibri" pitchFamily="34" charset="-120"/>
               </a:rPr>
-              <a:t>Wallet Partners LLC · Sponsor-bank briefing · September 2026 · Confidential</a:t>
+              <a:t>Wallet Partners LLC d/b/a Bombero Partners · Sponsor-bank briefing · September 2026 · Confidential</a:t>
             </a:r>
             <a:endParaRPr lang="en-US" sz="900" dirty="0"/>
           </a:p>
@@ -11543,7 +11543,7 @@
                 <a:ea typeface="Calibri" pitchFamily="34" charset="-122"/>
                 <a:cs typeface="Calibri" pitchFamily="34" charset="-120"/>
               </a:rPr>
-              <a:t>info@walletpartnersllc.com</a:t>
+              <a:t>info@walletpartnersllc.com  ·  bomberopartners.com.do</a:t>
             </a:r>
             <a:endParaRPr lang="en-US" sz="1300" dirty="0"/>
           </a:p>
@@ -11582,7 +11582,7 @@
                 <a:ea typeface="Calibri" pitchFamily="34" charset="-122"/>
                 <a:cs typeface="Calibri" pitchFamily="34" charset="-120"/>
               </a:rPr>
-              <a:t>Wallet Partners LLC  ·  Confidential</a:t>
+              <a:t>Wallet Partners LLC d/b/a Bombero Partners  ·  Confidential</a:t>
             </a:r>
             <a:endParaRPr lang="en-US" sz="1000" dirty="0"/>
           </a:p>
@@ -11653,7 +11653,7 @@
                 <a:ea typeface="Calibri" pitchFamily="34" charset="-122"/>
                 <a:cs typeface="Calibri" pitchFamily="34" charset="-120"/>
               </a:rPr>
-              <a:t>Wallet Partners LLC · Sponsor-bank briefing · September 2026 · Confidential</a:t>
+              <a:t>Wallet Partners LLC d/b/a Bombero Partners · Sponsor-bank briefing · September 2026 · Confidential</a:t>
             </a:r>
             <a:endParaRPr lang="en-US" sz="900" dirty="0"/>
           </a:p>
@@ -12305,7 +12305,7 @@
                 <a:ea typeface="Calibri" pitchFamily="34" charset="-122"/>
                 <a:cs typeface="Calibri" pitchFamily="34" charset="-120"/>
               </a:rPr>
-              <a:t>Wallet Partners LLC · Sponsor-bank briefing · September 2026 · Confidential</a:t>
+              <a:t>Wallet Partners LLC d/b/a Bombero Partners · Sponsor-bank briefing · September 2026 · Confidential</a:t>
             </a:r>
             <a:endParaRPr lang="en-US" sz="900" dirty="0"/>
           </a:p>
@@ -12780,7 +12780,7 @@
                 <a:ea typeface="Calibri" pitchFamily="34" charset="-122"/>
                 <a:cs typeface="Calibri" pitchFamily="34" charset="-120"/>
               </a:rPr>
-              <a:t>Wallet Partners operates as payment facilitator / program manager under your membership and oversight.</a:t>
+              <a:t>Wallet Partners LLC, trading in the DR as Bombero Partners, operates as payment facilitator / program manager under your membership and oversight.</a:t>
             </a:r>
             <a:endParaRPr lang="en-US" sz="1250" dirty="0"/>
           </a:p>
@@ -13093,7 +13093,7 @@
                 <a:ea typeface="Calibri" pitchFamily="34" charset="-122"/>
                 <a:cs typeface="Calibri" pitchFamily="34" charset="-120"/>
               </a:rPr>
-              <a:t>Wallet Partners LLC · Sponsor-bank briefing · September 2026 · Confidential</a:t>
+              <a:t>Wallet Partners LLC d/b/a Bombero Partners · Sponsor-bank briefing · September 2026 · Confidential</a:t>
             </a:r>
             <a:endParaRPr lang="en-US" sz="900" dirty="0"/>
           </a:p>
@@ -14002,7 +14002,7 @@
                 <a:ea typeface="Calibri" pitchFamily="34" charset="-122"/>
                 <a:cs typeface="Calibri" pitchFamily="34" charset="-120"/>
               </a:rPr>
-              <a:t>Wallet Partners LLC · Sponsor-bank briefing · September 2026 · Confidential</a:t>
+              <a:t>Wallet Partners LLC d/b/a Bombero Partners · Sponsor-bank briefing · September 2026 · Confidential</a:t>
             </a:r>
             <a:endParaRPr lang="en-US" sz="900" dirty="0"/>
           </a:p>
@@ -14638,7 +14638,7 @@
                 <a:ea typeface="Calibri" pitchFamily="34" charset="-122"/>
                 <a:cs typeface="Calibri" pitchFamily="34" charset="-120"/>
               </a:rPr>
-              <a:t>Wallet Partners LLC · Sponsor-bank briefing · September 2026 · Confidential</a:t>
+              <a:t>Wallet Partners LLC d/b/a Bombero Partners · Sponsor-bank briefing · September 2026 · Confidential</a:t>
             </a:r>
             <a:endParaRPr lang="en-US" sz="900" dirty="0"/>
           </a:p>
@@ -15706,7 +15706,7 @@
                 <a:ea typeface="Calibri" pitchFamily="34" charset="-122"/>
                 <a:cs typeface="Calibri" pitchFamily="34" charset="-120"/>
               </a:rPr>
-              <a:t>Wallet Partners LLC · Sponsor-bank briefing · September 2026 · Confidential</a:t>
+              <a:t>Wallet Partners LLC d/b/a Bombero Partners · Sponsor-bank briefing · September 2026 · Confidential</a:t>
             </a:r>
             <a:endParaRPr lang="en-US" sz="900" dirty="0"/>
           </a:p>
@@ -17381,7 +17381,7 @@
                 <a:ea typeface="Calibri" pitchFamily="34" charset="-122"/>
                 <a:cs typeface="Calibri" pitchFamily="34" charset="-120"/>
               </a:rPr>
-              <a:t>Wallet Partners LLC · Sponsor-bank briefing · September 2026 · Confidential</a:t>
+              <a:t>Wallet Partners LLC d/b/a Bombero Partners · Sponsor-bank briefing · September 2026 · Confidential</a:t>
             </a:r>
             <a:endParaRPr lang="en-US" sz="900" dirty="0"/>
           </a:p>
@@ -18064,7 +18064,7 @@
                 <a:ea typeface="Calibri" pitchFamily="34" charset="-122"/>
                 <a:cs typeface="Calibri" pitchFamily="34" charset="-120"/>
               </a:rPr>
-              <a:t>Wallet Partners LLC · Sponsor-bank briefing · September 2026 · Confidential</a:t>
+              <a:t>Wallet Partners LLC d/b/a Bombero Partners · Sponsor-bank briefing · September 2026 · Confidential</a:t>
             </a:r>
             <a:endParaRPr lang="en-US" sz="900" dirty="0"/>
           </a:p>
@@ -24054,7 +24054,7 @@
                 <a:ea typeface="Calibri" pitchFamily="34" charset="-122"/>
                 <a:cs typeface="Calibri" pitchFamily="34" charset="-120"/>
               </a:rPr>
-              <a:t>Wallet Partners LLC · Sponsor-bank briefing · September 2026 · Confidential</a:t>
+              <a:t>Wallet Partners LLC d/b/a Bombero Partners · Sponsor-bank briefing · September 2026 · Confidential</a:t>
             </a:r>
             <a:endParaRPr lang="en-US" sz="900" dirty="0"/>
           </a:p>

</xml_diff>